<commit_message>
docs: consolidate Bilim OS sales kit into PDFs
Replace scattered .docx (onboarding, demo script, concept, sales script,
competitor comparison, cheat sheet) with consolidated PDF deliverables
(guide, KP) generated via updated generators. Add make-bilim-pdf.mjs.

Co-Authored-By: Claude Opus 4.8 (1M context) <noreply@anthropic.com>
</commit_message>
<xml_diff>
--- a/docs/Bilim_OS_презентация.pptx
+++ b/docs/Bilim_OS_презентация.pptx
@@ -1869,7 +1869,7 @@
             <a:avLst/>
           </a:prstGeom>
           <a:solidFill>
-            <a:srgbClr val="E91E8C"/>
+            <a:srgbClr val="1971C2"/>
           </a:solidFill>
           <a:ln/>
         </p:spPr>
@@ -1915,7 +1915,7 @@
             <a:r>
               <a:rPr lang="en-US" sz="7200" b="1" dirty="0">
                 <a:solidFill>
-                  <a:srgbClr val="E91E8C"/>
+                  <a:srgbClr val="1971C2"/>
                 </a:solidFill>
                 <a:latin typeface="Calibri" pitchFamily="34" charset="0"/>
                 <a:ea typeface="Calibri" pitchFamily="34" charset="-122"/>
@@ -1993,7 +1993,7 @@
             <a:r>
               <a:rPr lang="en-US" sz="2000" b="1" dirty="0">
                 <a:solidFill>
-                  <a:srgbClr val="E91E8C"/>
+                  <a:srgbClr val="1971C2"/>
                 </a:solidFill>
                 <a:latin typeface="Calibri" pitchFamily="34" charset="0"/>
                 <a:ea typeface="Calibri" pitchFamily="34" charset="-122"/>
@@ -2046,7 +2046,7 @@
             <a:r>
               <a:rPr lang="en-US" sz="1600" u="sng" dirty="0">
                 <a:solidFill>
-                  <a:srgbClr val="E91E8C"/>
+                  <a:srgbClr val="1971C2"/>
                 </a:solidFill>
                 <a:latin typeface="Calibri" pitchFamily="34" charset="0"/>
                 <a:ea typeface="Calibri" pitchFamily="34" charset="-122"/>
@@ -2165,7 +2165,7 @@
             <a:avLst/>
           </a:prstGeom>
           <a:solidFill>
-            <a:srgbClr val="E91E8C"/>
+            <a:srgbClr val="1971C2"/>
           </a:solidFill>
           <a:ln/>
         </p:spPr>
@@ -2309,7 +2309,7 @@
             <a:r>
               <a:rPr lang="en-US" sz="2000" b="1" dirty="0">
                 <a:solidFill>
-                  <a:srgbClr val="E91E8C"/>
+                  <a:srgbClr val="1971C2"/>
                 </a:solidFill>
                 <a:latin typeface="Calibri" pitchFamily="34" charset="0"/>
                 <a:ea typeface="Calibri" pitchFamily="34" charset="-122"/>
@@ -2337,7 +2337,7 @@
             <a:r>
               <a:rPr lang="en-US" sz="2000" b="1" dirty="0">
                 <a:solidFill>
-                  <a:srgbClr val="E91E8C"/>
+                  <a:srgbClr val="1971C2"/>
                 </a:solidFill>
                 <a:latin typeface="Calibri" pitchFamily="34" charset="0"/>
                 <a:ea typeface="Calibri" pitchFamily="34" charset="-122"/>
@@ -2755,7 +2755,7 @@
                       <a:tailEnd type="none" w="med" len="med"/>
                     </a:lnB>
                     <a:solidFill>
-                      <a:srgbClr val="F7E9F1"/>
+                      <a:srgbClr val="E7F1FB"/>
                     </a:solidFill>
                   </a:tcPr>
                 </a:tc>
@@ -2823,7 +2823,7 @@
                       <a:tailEnd type="none" w="med" len="med"/>
                     </a:lnB>
                     <a:solidFill>
-                      <a:srgbClr val="F7E9F1"/>
+                      <a:srgbClr val="E7F1FB"/>
                     </a:solidFill>
                   </a:tcPr>
                 </a:tc>
@@ -3031,7 +3031,7 @@
                       <a:tailEnd type="none" w="med" len="med"/>
                     </a:lnB>
                     <a:solidFill>
-                      <a:srgbClr val="F7E9F1"/>
+                      <a:srgbClr val="E7F1FB"/>
                     </a:solidFill>
                   </a:tcPr>
                 </a:tc>
@@ -3099,7 +3099,7 @@
                       <a:tailEnd type="none" w="med" len="med"/>
                     </a:lnB>
                     <a:solidFill>
-                      <a:srgbClr val="F7E9F1"/>
+                      <a:srgbClr val="E7F1FB"/>
                     </a:solidFill>
                   </a:tcPr>
                 </a:tc>
@@ -3307,7 +3307,7 @@
                       <a:tailEnd type="none" w="med" len="med"/>
                     </a:lnB>
                     <a:solidFill>
-                      <a:srgbClr val="F7E9F1"/>
+                      <a:srgbClr val="E7F1FB"/>
                     </a:solidFill>
                   </a:tcPr>
                 </a:tc>
@@ -3375,7 +3375,7 @@
                       <a:tailEnd type="none" w="med" len="med"/>
                     </a:lnB>
                     <a:solidFill>
-                      <a:srgbClr val="F7E9F1"/>
+                      <a:srgbClr val="E7F1FB"/>
                     </a:solidFill>
                   </a:tcPr>
                 </a:tc>
@@ -3583,7 +3583,7 @@
                       <a:tailEnd type="none" w="med" len="med"/>
                     </a:lnB>
                     <a:solidFill>
-                      <a:srgbClr val="F7E9F1"/>
+                      <a:srgbClr val="E7F1FB"/>
                     </a:solidFill>
                   </a:tcPr>
                 </a:tc>
@@ -3651,7 +3651,7 @@
                       <a:tailEnd type="none" w="med" len="med"/>
                     </a:lnB>
                     <a:solidFill>
-                      <a:srgbClr val="F7E9F1"/>
+                      <a:srgbClr val="E7F1FB"/>
                     </a:solidFill>
                   </a:tcPr>
                 </a:tc>
@@ -3859,7 +3859,7 @@
                       <a:tailEnd type="none" w="med" len="med"/>
                     </a:lnB>
                     <a:solidFill>
-                      <a:srgbClr val="F7E9F1"/>
+                      <a:srgbClr val="E7F1FB"/>
                     </a:solidFill>
                   </a:tcPr>
                 </a:tc>
@@ -3927,7 +3927,7 @@
                       <a:tailEnd type="none" w="med" len="med"/>
                     </a:lnB>
                     <a:solidFill>
-                      <a:srgbClr val="F7E9F1"/>
+                      <a:srgbClr val="E7F1FB"/>
                     </a:solidFill>
                   </a:tcPr>
                 </a:tc>
@@ -3997,7 +3997,7 @@
                       <a:tailEnd type="none" w="med" len="med"/>
                     </a:lnB>
                     <a:solidFill>
-                      <a:srgbClr val="E91E8C"/>
+                      <a:srgbClr val="1971C2"/>
                     </a:solidFill>
                   </a:tcPr>
                 </a:tc>
@@ -4065,7 +4065,7 @@
                       <a:tailEnd type="none" w="med" len="med"/>
                     </a:lnB>
                     <a:solidFill>
-                      <a:srgbClr val="E91E8C"/>
+                      <a:srgbClr val="1971C2"/>
                     </a:solidFill>
                   </a:tcPr>
                 </a:tc>
@@ -4160,7 +4160,7 @@
             <a:avLst/>
           </a:prstGeom>
           <a:solidFill>
-            <a:srgbClr val="E91E8C"/>
+            <a:srgbClr val="1971C2"/>
           </a:solidFill>
           <a:ln/>
         </p:spPr>
@@ -4304,7 +4304,7 @@
             <a:r>
               <a:rPr lang="en-US" sz="2000" b="1" u="sng" dirty="0">
                 <a:solidFill>
-                  <a:srgbClr val="E91E8C"/>
+                  <a:srgbClr val="1971C2"/>
                 </a:solidFill>
                 <a:latin typeface="Calibri" pitchFamily="34" charset="0"/>
                 <a:ea typeface="Calibri" pitchFamily="34" charset="-122"/>
@@ -4350,7 +4350,7 @@
             <a:r>
               <a:rPr lang="en-US" sz="1600" b="1" dirty="0">
                 <a:solidFill>
-                  <a:srgbClr val="E91E8C"/>
+                  <a:srgbClr val="1971C2"/>
                 </a:solidFill>
                 <a:latin typeface="Calibri" pitchFamily="34" charset="0"/>
                 <a:ea typeface="Calibri" pitchFamily="34" charset="-122"/>
@@ -4591,7 +4591,7 @@
                       <a:tailEnd type="none" w="med" len="med"/>
                     </a:lnB>
                     <a:solidFill>
-                      <a:srgbClr val="F7E9F1"/>
+                      <a:srgbClr val="E7F1FB"/>
                     </a:solidFill>
                   </a:tcPr>
                 </a:tc>
@@ -4659,7 +4659,7 @@
                       <a:tailEnd type="none" w="med" len="med"/>
                     </a:lnB>
                     <a:solidFill>
-                      <a:srgbClr val="F7E9F1"/>
+                      <a:srgbClr val="E7F1FB"/>
                     </a:solidFill>
                   </a:tcPr>
                 </a:tc>
@@ -4867,7 +4867,7 @@
                       <a:tailEnd type="none" w="med" len="med"/>
                     </a:lnB>
                     <a:solidFill>
-                      <a:srgbClr val="F7E9F1"/>
+                      <a:srgbClr val="E7F1FB"/>
                     </a:solidFill>
                   </a:tcPr>
                 </a:tc>
@@ -4935,7 +4935,7 @@
                       <a:tailEnd type="none" w="med" len="med"/>
                     </a:lnB>
                     <a:solidFill>
-                      <a:srgbClr val="F7E9F1"/>
+                      <a:srgbClr val="E7F1FB"/>
                     </a:solidFill>
                   </a:tcPr>
                 </a:tc>
@@ -5135,7 +5135,7 @@
     <p:bg>
       <p:bgPr>
         <a:solidFill>
-          <a:srgbClr val="E91E8C"/>
+          <a:srgbClr val="1971C2"/>
         </a:solidFill>
       </p:bgPr>
     </p:bg>
@@ -5338,7 +5338,7 @@
             <a:avLst/>
           </a:prstGeom>
           <a:solidFill>
-            <a:srgbClr val="E91E8C"/>
+            <a:srgbClr val="1971C2"/>
           </a:solidFill>
           <a:ln/>
         </p:spPr>
@@ -5468,7 +5468,7 @@
             <a:r>
               <a:rPr lang="en-US" sz="2000" b="1" dirty="0">
                 <a:solidFill>
-                  <a:srgbClr val="E91E8C"/>
+                  <a:srgbClr val="1971C2"/>
                 </a:solidFill>
                 <a:latin typeface="Calibri" pitchFamily="34" charset="0"/>
                 <a:ea typeface="Calibri" pitchFamily="34" charset="-122"/>
@@ -5633,7 +5633,7 @@
             <a:avLst/>
           </a:prstGeom>
           <a:solidFill>
-            <a:srgbClr val="E91E8C"/>
+            <a:srgbClr val="1971C2"/>
           </a:solidFill>
           <a:ln/>
         </p:spPr>
@@ -5910,7 +5910,7 @@
             <a:avLst/>
           </a:prstGeom>
           <a:solidFill>
-            <a:srgbClr val="E91E8C"/>
+            <a:srgbClr val="1971C2"/>
           </a:solidFill>
           <a:ln/>
         </p:spPr>
@@ -6242,7 +6242,7 @@
                       <a:tailEnd type="none" w="med" len="med"/>
                     </a:lnB>
                     <a:solidFill>
-                      <a:srgbClr val="F7E9F1"/>
+                      <a:srgbClr val="E7F1FB"/>
                     </a:solidFill>
                   </a:tcPr>
                 </a:tc>
@@ -6310,7 +6310,7 @@
                       <a:tailEnd type="none" w="med" len="med"/>
                     </a:lnB>
                     <a:solidFill>
-                      <a:srgbClr val="F7E9F1"/>
+                      <a:srgbClr val="E7F1FB"/>
                     </a:solidFill>
                   </a:tcPr>
                 </a:tc>
@@ -6518,7 +6518,7 @@
                       <a:tailEnd type="none" w="med" len="med"/>
                     </a:lnB>
                     <a:solidFill>
-                      <a:srgbClr val="F7E9F1"/>
+                      <a:srgbClr val="E7F1FB"/>
                     </a:solidFill>
                   </a:tcPr>
                 </a:tc>
@@ -6586,7 +6586,7 @@
                       <a:tailEnd type="none" w="med" len="med"/>
                     </a:lnB>
                     <a:solidFill>
-                      <a:srgbClr val="F7E9F1"/>
+                      <a:srgbClr val="E7F1FB"/>
                     </a:solidFill>
                   </a:tcPr>
                 </a:tc>
@@ -6794,7 +6794,7 @@
                       <a:tailEnd type="none" w="med" len="med"/>
                     </a:lnB>
                     <a:solidFill>
-                      <a:srgbClr val="F7E9F1"/>
+                      <a:srgbClr val="E7F1FB"/>
                     </a:solidFill>
                   </a:tcPr>
                 </a:tc>
@@ -6862,7 +6862,7 @@
                       <a:tailEnd type="none" w="med" len="med"/>
                     </a:lnB>
                     <a:solidFill>
-                      <a:srgbClr val="F7E9F1"/>
+                      <a:srgbClr val="E7F1FB"/>
                     </a:solidFill>
                   </a:tcPr>
                 </a:tc>
@@ -7070,7 +7070,7 @@
                       <a:tailEnd type="none" w="med" len="med"/>
                     </a:lnB>
                     <a:solidFill>
-                      <a:srgbClr val="F7E9F1"/>
+                      <a:srgbClr val="E7F1FB"/>
                     </a:solidFill>
                   </a:tcPr>
                 </a:tc>
@@ -7138,7 +7138,7 @@
                       <a:tailEnd type="none" w="med" len="med"/>
                     </a:lnB>
                     <a:solidFill>
-                      <a:srgbClr val="F7E9F1"/>
+                      <a:srgbClr val="E7F1FB"/>
                     </a:solidFill>
                   </a:tcPr>
                 </a:tc>
@@ -7332,7 +7332,7 @@
             <a:avLst/>
           </a:prstGeom>
           <a:solidFill>
-            <a:srgbClr val="E91E8C"/>
+            <a:srgbClr val="1971C2"/>
           </a:solidFill>
           <a:ln/>
         </p:spPr>
@@ -7452,11 +7452,11 @@
             </a:avLst>
           </a:prstGeom>
           <a:solidFill>
-            <a:srgbClr val="F7E9F1"/>
+            <a:srgbClr val="E7F1FB"/>
           </a:solidFill>
           <a:ln w="9525">
             <a:solidFill>
-              <a:srgbClr val="E91E8C"/>
+              <a:srgbClr val="1971C2"/>
             </a:solidFill>
             <a:prstDash val="solid"/>
           </a:ln>
@@ -7518,11 +7518,11 @@
             </a:avLst>
           </a:prstGeom>
           <a:solidFill>
-            <a:srgbClr val="F7E9F1"/>
+            <a:srgbClr val="E7F1FB"/>
           </a:solidFill>
           <a:ln w="9525">
             <a:solidFill>
-              <a:srgbClr val="E91E8C"/>
+              <a:srgbClr val="1971C2"/>
             </a:solidFill>
             <a:prstDash val="solid"/>
           </a:ln>
@@ -7584,11 +7584,11 @@
             </a:avLst>
           </a:prstGeom>
           <a:solidFill>
-            <a:srgbClr val="F7E9F1"/>
+            <a:srgbClr val="E7F1FB"/>
           </a:solidFill>
           <a:ln w="9525">
             <a:solidFill>
-              <a:srgbClr val="E91E8C"/>
+              <a:srgbClr val="1971C2"/>
             </a:solidFill>
             <a:prstDash val="solid"/>
           </a:ln>
@@ -7650,11 +7650,11 @@
             </a:avLst>
           </a:prstGeom>
           <a:solidFill>
-            <a:srgbClr val="F7E9F1"/>
+            <a:srgbClr val="E7F1FB"/>
           </a:solidFill>
           <a:ln w="9525">
             <a:solidFill>
-              <a:srgbClr val="E91E8C"/>
+              <a:srgbClr val="1971C2"/>
             </a:solidFill>
             <a:prstDash val="solid"/>
           </a:ln>
@@ -7716,11 +7716,11 @@
             </a:avLst>
           </a:prstGeom>
           <a:solidFill>
-            <a:srgbClr val="F7E9F1"/>
+            <a:srgbClr val="E7F1FB"/>
           </a:solidFill>
           <a:ln w="9525">
             <a:solidFill>
-              <a:srgbClr val="E91E8C"/>
+              <a:srgbClr val="1971C2"/>
             </a:solidFill>
             <a:prstDash val="solid"/>
           </a:ln>
@@ -7782,11 +7782,11 @@
             </a:avLst>
           </a:prstGeom>
           <a:solidFill>
-            <a:srgbClr val="F7E9F1"/>
+            <a:srgbClr val="E7F1FB"/>
           </a:solidFill>
           <a:ln w="9525">
             <a:solidFill>
-              <a:srgbClr val="E91E8C"/>
+              <a:srgbClr val="1971C2"/>
             </a:solidFill>
             <a:prstDash val="solid"/>
           </a:ln>
@@ -7848,11 +7848,11 @@
             </a:avLst>
           </a:prstGeom>
           <a:solidFill>
-            <a:srgbClr val="F7E9F1"/>
+            <a:srgbClr val="E7F1FB"/>
           </a:solidFill>
           <a:ln w="9525">
             <a:solidFill>
-              <a:srgbClr val="E91E8C"/>
+              <a:srgbClr val="1971C2"/>
             </a:solidFill>
             <a:prstDash val="solid"/>
           </a:ln>
@@ -7914,11 +7914,11 @@
             </a:avLst>
           </a:prstGeom>
           <a:solidFill>
-            <a:srgbClr val="F7E9F1"/>
+            <a:srgbClr val="E7F1FB"/>
           </a:solidFill>
           <a:ln w="9525">
             <a:solidFill>
-              <a:srgbClr val="E91E8C"/>
+              <a:srgbClr val="1971C2"/>
             </a:solidFill>
             <a:prstDash val="solid"/>
           </a:ln>
@@ -7980,11 +7980,11 @@
             </a:avLst>
           </a:prstGeom>
           <a:solidFill>
-            <a:srgbClr val="F7E9F1"/>
+            <a:srgbClr val="E7F1FB"/>
           </a:solidFill>
           <a:ln w="9525">
             <a:solidFill>
-              <a:srgbClr val="E91E8C"/>
+              <a:srgbClr val="1971C2"/>
             </a:solidFill>
             <a:prstDash val="solid"/>
           </a:ln>
@@ -8046,11 +8046,11 @@
             </a:avLst>
           </a:prstGeom>
           <a:solidFill>
-            <a:srgbClr val="F7E9F1"/>
+            <a:srgbClr val="E7F1FB"/>
           </a:solidFill>
           <a:ln w="9525">
             <a:solidFill>
-              <a:srgbClr val="E91E8C"/>
+              <a:srgbClr val="1971C2"/>
             </a:solidFill>
             <a:prstDash val="solid"/>
           </a:ln>
@@ -8112,11 +8112,11 @@
             </a:avLst>
           </a:prstGeom>
           <a:solidFill>
-            <a:srgbClr val="F7E9F1"/>
+            <a:srgbClr val="E7F1FB"/>
           </a:solidFill>
           <a:ln w="9525">
             <a:solidFill>
-              <a:srgbClr val="E91E8C"/>
+              <a:srgbClr val="1971C2"/>
             </a:solidFill>
             <a:prstDash val="solid"/>
           </a:ln>
@@ -8178,11 +8178,11 @@
             </a:avLst>
           </a:prstGeom>
           <a:solidFill>
-            <a:srgbClr val="F7E9F1"/>
+            <a:srgbClr val="E7F1FB"/>
           </a:solidFill>
           <a:ln w="9525">
             <a:solidFill>
-              <a:srgbClr val="E91E8C"/>
+              <a:srgbClr val="1971C2"/>
             </a:solidFill>
             <a:prstDash val="solid"/>
           </a:ln>
@@ -8244,11 +8244,11 @@
             </a:avLst>
           </a:prstGeom>
           <a:solidFill>
-            <a:srgbClr val="F7E9F1"/>
+            <a:srgbClr val="E7F1FB"/>
           </a:solidFill>
           <a:ln w="9525">
             <a:solidFill>
-              <a:srgbClr val="E91E8C"/>
+              <a:srgbClr val="1971C2"/>
             </a:solidFill>
             <a:prstDash val="solid"/>
           </a:ln>
@@ -8310,11 +8310,11 @@
             </a:avLst>
           </a:prstGeom>
           <a:solidFill>
-            <a:srgbClr val="F7E9F1"/>
+            <a:srgbClr val="E7F1FB"/>
           </a:solidFill>
           <a:ln w="9525">
             <a:solidFill>
-              <a:srgbClr val="E91E8C"/>
+              <a:srgbClr val="1971C2"/>
             </a:solidFill>
             <a:prstDash val="solid"/>
           </a:ln>
@@ -8376,11 +8376,11 @@
             </a:avLst>
           </a:prstGeom>
           <a:solidFill>
-            <a:srgbClr val="F7E9F1"/>
+            <a:srgbClr val="E7F1FB"/>
           </a:solidFill>
           <a:ln w="9525">
             <a:solidFill>
-              <a:srgbClr val="E91E8C"/>
+              <a:srgbClr val="1971C2"/>
             </a:solidFill>
             <a:prstDash val="solid"/>
           </a:ln>
@@ -8442,11 +8442,11 @@
             </a:avLst>
           </a:prstGeom>
           <a:solidFill>
-            <a:srgbClr val="F7E9F1"/>
+            <a:srgbClr val="E7F1FB"/>
           </a:solidFill>
           <a:ln w="9525">
             <a:solidFill>
-              <a:srgbClr val="E91E8C"/>
+              <a:srgbClr val="1971C2"/>
             </a:solidFill>
             <a:prstDash val="solid"/>
           </a:ln>
@@ -8508,11 +8508,11 @@
             </a:avLst>
           </a:prstGeom>
           <a:solidFill>
-            <a:srgbClr val="F7E9F1"/>
+            <a:srgbClr val="E7F1FB"/>
           </a:solidFill>
           <a:ln w="9525">
             <a:solidFill>
-              <a:srgbClr val="E91E8C"/>
+              <a:srgbClr val="1971C2"/>
             </a:solidFill>
             <a:prstDash val="solid"/>
           </a:ln>
@@ -8574,11 +8574,11 @@
             </a:avLst>
           </a:prstGeom>
           <a:solidFill>
-            <a:srgbClr val="F7E9F1"/>
+            <a:srgbClr val="E7F1FB"/>
           </a:solidFill>
           <a:ln w="9525">
             <a:solidFill>
-              <a:srgbClr val="E91E8C"/>
+              <a:srgbClr val="1971C2"/>
             </a:solidFill>
             <a:prstDash val="solid"/>
           </a:ln>
@@ -8670,7 +8670,7 @@
             <a:avLst/>
           </a:prstGeom>
           <a:solidFill>
-            <a:srgbClr val="E91E8C"/>
+            <a:srgbClr val="1971C2"/>
           </a:solidFill>
           <a:ln/>
         </p:spPr>
@@ -8829,11 +8829,11 @@
             </a:avLst>
           </a:prstGeom>
           <a:solidFill>
-            <a:srgbClr val="F7E9F1"/>
+            <a:srgbClr val="E7F1FB"/>
           </a:solidFill>
           <a:ln w="15875">
             <a:solidFill>
-              <a:srgbClr val="E91E8C"/>
+              <a:srgbClr val="1971C2"/>
             </a:solidFill>
             <a:prstDash val="solid"/>
           </a:ln>
@@ -8920,7 +8920,7 @@
             <a:r>
               <a:rPr lang="en-US" sz="2600" b="1" dirty="0">
                 <a:solidFill>
-                  <a:srgbClr val="E91E8C"/>
+                  <a:srgbClr val="1971C2"/>
                 </a:solidFill>
                 <a:latin typeface="Calibri" pitchFamily="34" charset="0"/>
                 <a:ea typeface="Calibri" pitchFamily="34" charset="-122"/>
@@ -8949,11 +8949,11 @@
             </a:avLst>
           </a:prstGeom>
           <a:solidFill>
-            <a:srgbClr val="F7E9F1"/>
+            <a:srgbClr val="E7F1FB"/>
           </a:solidFill>
           <a:ln w="15875">
             <a:solidFill>
-              <a:srgbClr val="E91E8C"/>
+              <a:srgbClr val="1971C2"/>
             </a:solidFill>
             <a:prstDash val="solid"/>
           </a:ln>
@@ -9040,7 +9040,7 @@
             <a:r>
               <a:rPr lang="en-US" sz="2600" b="1" dirty="0">
                 <a:solidFill>
-                  <a:srgbClr val="E91E8C"/>
+                  <a:srgbClr val="1971C2"/>
                 </a:solidFill>
                 <a:latin typeface="Calibri" pitchFamily="34" charset="0"/>
                 <a:ea typeface="Calibri" pitchFamily="34" charset="-122"/>
@@ -9069,11 +9069,11 @@
             </a:avLst>
           </a:prstGeom>
           <a:solidFill>
-            <a:srgbClr val="F7E9F1"/>
+            <a:srgbClr val="E7F1FB"/>
           </a:solidFill>
           <a:ln w="15875">
             <a:solidFill>
-              <a:srgbClr val="E91E8C"/>
+              <a:srgbClr val="1971C2"/>
             </a:solidFill>
             <a:prstDash val="solid"/>
           </a:ln>
@@ -9160,7 +9160,7 @@
             <a:r>
               <a:rPr lang="en-US" sz="2600" b="1" dirty="0">
                 <a:solidFill>
-                  <a:srgbClr val="E91E8C"/>
+                  <a:srgbClr val="1971C2"/>
                 </a:solidFill>
                 <a:latin typeface="Calibri" pitchFamily="34" charset="0"/>
                 <a:ea typeface="Calibri" pitchFamily="34" charset="-122"/>
@@ -9189,11 +9189,11 @@
             </a:avLst>
           </a:prstGeom>
           <a:solidFill>
-            <a:srgbClr val="E91E8C"/>
+            <a:srgbClr val="1971C2"/>
           </a:solidFill>
           <a:ln w="15875">
             <a:solidFill>
-              <a:srgbClr val="E91E8C"/>
+              <a:srgbClr val="1971C2"/>
             </a:solidFill>
             <a:prstDash val="solid"/>
           </a:ln>
@@ -9339,7 +9339,7 @@
             <a:avLst/>
           </a:prstGeom>
           <a:solidFill>
-            <a:srgbClr val="E91E8C"/>
+            <a:srgbClr val="1971C2"/>
           </a:solidFill>
           <a:ln/>
         </p:spPr>
@@ -9472,7 +9472,7 @@
             <a:r>
               <a:rPr lang="en-US" sz="1700" b="1" dirty="0">
                 <a:solidFill>
-                  <a:srgbClr val="E91E8C"/>
+                  <a:srgbClr val="1971C2"/>
                 </a:solidFill>
                 <a:latin typeface="Calibri" pitchFamily="34" charset="0"/>
                 <a:ea typeface="Calibri" pitchFamily="34" charset="-122"/>
@@ -9508,7 +9508,7 @@
             <a:r>
               <a:rPr lang="en-US" sz="1700" b="1" dirty="0">
                 <a:solidFill>
-                  <a:srgbClr val="E91E8C"/>
+                  <a:srgbClr val="1971C2"/>
                 </a:solidFill>
                 <a:latin typeface="Calibri" pitchFamily="34" charset="0"/>
                 <a:ea typeface="Calibri" pitchFamily="34" charset="-122"/>
@@ -9544,7 +9544,7 @@
             <a:r>
               <a:rPr lang="en-US" sz="1700" b="1" dirty="0">
                 <a:solidFill>
-                  <a:srgbClr val="E91E8C"/>
+                  <a:srgbClr val="1971C2"/>
                 </a:solidFill>
                 <a:latin typeface="Calibri" pitchFamily="34" charset="0"/>
                 <a:ea typeface="Calibri" pitchFamily="34" charset="-122"/>
@@ -9621,7 +9621,7 @@
             <a:avLst/>
           </a:prstGeom>
           <a:solidFill>
-            <a:srgbClr val="E91E8C"/>
+            <a:srgbClr val="1971C2"/>
           </a:solidFill>
           <a:ln/>
         </p:spPr>
@@ -9958,7 +9958,7 @@
             <a:avLst/>
           </a:prstGeom>
           <a:solidFill>
-            <a:srgbClr val="E91E8C"/>
+            <a:srgbClr val="1971C2"/>
           </a:solidFill>
           <a:ln/>
         </p:spPr>
@@ -10260,7 +10260,7 @@
                       <a:tailEnd type="none" w="med" len="med"/>
                     </a:lnB>
                     <a:solidFill>
-                      <a:srgbClr val="E91E8C"/>
+                      <a:srgbClr val="1971C2"/>
                     </a:solidFill>
                   </a:tcPr>
                 </a:tc>
@@ -10604,7 +10604,7 @@
                       <a:tailEnd type="none" w="med" len="med"/>
                     </a:lnB>
                     <a:solidFill>
-                      <a:srgbClr val="F7E9F1"/>
+                      <a:srgbClr val="E7F1FB"/>
                     </a:solidFill>
                   </a:tcPr>
                 </a:tc>
@@ -10672,7 +10672,7 @@
                       <a:tailEnd type="none" w="med" len="med"/>
                     </a:lnB>
                     <a:solidFill>
-                      <a:srgbClr val="F7E9F1"/>
+                      <a:srgbClr val="E7F1FB"/>
                     </a:solidFill>
                   </a:tcPr>
                 </a:tc>
@@ -10740,7 +10740,7 @@
                       <a:tailEnd type="none" w="med" len="med"/>
                     </a:lnB>
                     <a:solidFill>
-                      <a:srgbClr val="F7E9F1"/>
+                      <a:srgbClr val="E7F1FB"/>
                     </a:solidFill>
                   </a:tcPr>
                 </a:tc>
@@ -11016,7 +11016,7 @@
                       <a:tailEnd type="none" w="med" len="med"/>
                     </a:lnB>
                     <a:solidFill>
-                      <a:srgbClr val="F7E9F1"/>
+                      <a:srgbClr val="E7F1FB"/>
                     </a:solidFill>
                   </a:tcPr>
                 </a:tc>
@@ -11084,7 +11084,7 @@
                       <a:tailEnd type="none" w="med" len="med"/>
                     </a:lnB>
                     <a:solidFill>
-                      <a:srgbClr val="F7E9F1"/>
+                      <a:srgbClr val="E7F1FB"/>
                     </a:solidFill>
                   </a:tcPr>
                 </a:tc>
@@ -11152,7 +11152,7 @@
                       <a:tailEnd type="none" w="med" len="med"/>
                     </a:lnB>
                     <a:solidFill>
-                      <a:srgbClr val="F7E9F1"/>
+                      <a:srgbClr val="E7F1FB"/>
                     </a:solidFill>
                   </a:tcPr>
                 </a:tc>
@@ -11428,7 +11428,7 @@
                       <a:tailEnd type="none" w="med" len="med"/>
                     </a:lnB>
                     <a:solidFill>
-                      <a:srgbClr val="F7E9F1"/>
+                      <a:srgbClr val="E7F1FB"/>
                     </a:solidFill>
                   </a:tcPr>
                 </a:tc>
@@ -11496,7 +11496,7 @@
                       <a:tailEnd type="none" w="med" len="med"/>
                     </a:lnB>
                     <a:solidFill>
-                      <a:srgbClr val="F7E9F1"/>
+                      <a:srgbClr val="E7F1FB"/>
                     </a:solidFill>
                   </a:tcPr>
                 </a:tc>
@@ -11564,7 +11564,7 @@
                       <a:tailEnd type="none" w="med" len="med"/>
                     </a:lnB>
                     <a:solidFill>
-                      <a:srgbClr val="F7E9F1"/>
+                      <a:srgbClr val="E7F1FB"/>
                     </a:solidFill>
                   </a:tcPr>
                 </a:tc>

</xml_diff>